<commit_message>
Worked on slides and ideas some more
</commit_message>
<xml_diff>
--- a/MicrosoftAgentFrameworkWorkshop-DotNetDeveloperDays-Warsaw-2026.pptx
+++ b/MicrosoftAgentFrameworkWorkshop-DotNetDeveloperDays-Warsaw-2026.pptx
@@ -15,6 +15,17 @@
     <p:sldId id="263" r:id="slide8"/>
     <p:sldId id="264" r:id="slide9"/>
     <p:sldId id="265" r:id="slide10"/>
+    <p:sldId id="266" r:id="slide11"/>
+    <p:sldId id="267" r:id="slide12"/>
+    <p:sldId id="268" r:id="slide13"/>
+    <p:sldId id="269" r:id="slide14"/>
+    <p:sldId id="270" r:id="slide15"/>
+    <p:sldId id="271" r:id="slide16"/>
+    <p:sldId id="272" r:id="slide17"/>
+    <p:sldId id="273" r:id="slide18"/>
+    <p:sldId id="274" r:id="slide19"/>
+    <p:sldId id="275" r:id="slide20"/>
+    <p:sldId id="276" r:id="slide21"/>
   </p:sldIdLst>
   <p:sldSz cx="12192000" cy="6858000" type="screen16x9"/>
   <p:notesSz cx="6858000" cy="9144000"/>
@@ -170,6 +181,447 @@
 </p:sld>
 </file>
 
+<file path=ppt/slides/slide11.xml><?xml version="1.0" encoding="utf-8"?>
+<p:sld xmlns:p="http://schemas.openxmlformats.org/presentationml/2006/main" xmlns:a="http://schemas.openxmlformats.org/drawingml/2006/main" xmlns:r="http://schemas.openxmlformats.org/officeDocument/2006/relationships">
+  <p:cSld name="slide-11">
+    <p:spTree>
+      <p:nvGrpSpPr>
+        <p:cNvPr id="1" name=""/>
+        <p:cNvGrpSpPr/>
+        <p:nvPr/>
+      </p:nvGrpSpPr>
+      <p:grpSpPr>
+        <a:xfrm>
+          <a:off x="0" y="0"/>
+          <a:ext cx="0" cy="0"/>
+          <a:chOff x="0" y="0"/>
+          <a:chExt cx="0" cy="0"/>
+        </a:xfrm>
+      </p:grpSpPr>
+      <p:pic>
+        <p:nvPicPr>
+          <p:cNvPr id="2" name="slide-11"/>
+          <p:cNvPicPr>
+            <a:picLocks noChangeAspect="1"/>
+          </p:cNvPicPr>
+          <p:nvPr/>
+        </p:nvPicPr>
+        <p:blipFill>
+          <a:blip r:embed="image"/>
+          <a:stretch>
+            <a:fillRect/>
+          </a:stretch>
+        </p:blipFill>
+        <p:spPr>
+          <a:xfrm>
+            <a:off x="0" y="0"/>
+            <a:ext cx="12192000" cy="6858000"/>
+          </a:xfrm>
+          <a:prstGeom prst="rect">
+            <a:avLst/>
+          </a:prstGeom>
+        </p:spPr>
+      </p:pic>
+    </p:spTree>
+  </p:cSld>
+  <p:clrMapOvr>
+    <a:masterClrMapping/>
+  </p:clrMapOvr>
+</p:sld>
+</file>
+
+<file path=ppt/slides/slide12.xml><?xml version="1.0" encoding="utf-8"?>
+<p:sld xmlns:p="http://schemas.openxmlformats.org/presentationml/2006/main" xmlns:a="http://schemas.openxmlformats.org/drawingml/2006/main" xmlns:r="http://schemas.openxmlformats.org/officeDocument/2006/relationships">
+  <p:cSld name="slide-12">
+    <p:spTree>
+      <p:nvGrpSpPr>
+        <p:cNvPr id="1" name=""/>
+        <p:cNvGrpSpPr/>
+        <p:nvPr/>
+      </p:nvGrpSpPr>
+      <p:grpSpPr>
+        <a:xfrm>
+          <a:off x="0" y="0"/>
+          <a:ext cx="0" cy="0"/>
+          <a:chOff x="0" y="0"/>
+          <a:chExt cx="0" cy="0"/>
+        </a:xfrm>
+      </p:grpSpPr>
+      <p:pic>
+        <p:nvPicPr>
+          <p:cNvPr id="2" name="slide-12"/>
+          <p:cNvPicPr>
+            <a:picLocks noChangeAspect="1"/>
+          </p:cNvPicPr>
+          <p:nvPr/>
+        </p:nvPicPr>
+        <p:blipFill>
+          <a:blip r:embed="image"/>
+          <a:stretch>
+            <a:fillRect/>
+          </a:stretch>
+        </p:blipFill>
+        <p:spPr>
+          <a:xfrm>
+            <a:off x="0" y="0"/>
+            <a:ext cx="12192000" cy="6858000"/>
+          </a:xfrm>
+          <a:prstGeom prst="rect">
+            <a:avLst/>
+          </a:prstGeom>
+        </p:spPr>
+      </p:pic>
+    </p:spTree>
+  </p:cSld>
+  <p:clrMapOvr>
+    <a:masterClrMapping/>
+  </p:clrMapOvr>
+</p:sld>
+</file>
+
+<file path=ppt/slides/slide13.xml><?xml version="1.0" encoding="utf-8"?>
+<p:sld xmlns:p="http://schemas.openxmlformats.org/presentationml/2006/main" xmlns:a="http://schemas.openxmlformats.org/drawingml/2006/main" xmlns:r="http://schemas.openxmlformats.org/officeDocument/2006/relationships">
+  <p:cSld name="slide-13">
+    <p:spTree>
+      <p:nvGrpSpPr>
+        <p:cNvPr id="1" name=""/>
+        <p:cNvGrpSpPr/>
+        <p:nvPr/>
+      </p:nvGrpSpPr>
+      <p:grpSpPr>
+        <a:xfrm>
+          <a:off x="0" y="0"/>
+          <a:ext cx="0" cy="0"/>
+          <a:chOff x="0" y="0"/>
+          <a:chExt cx="0" cy="0"/>
+        </a:xfrm>
+      </p:grpSpPr>
+      <p:pic>
+        <p:nvPicPr>
+          <p:cNvPr id="2" name="slide-13"/>
+          <p:cNvPicPr>
+            <a:picLocks noChangeAspect="1"/>
+          </p:cNvPicPr>
+          <p:nvPr/>
+        </p:nvPicPr>
+        <p:blipFill>
+          <a:blip r:embed="image"/>
+          <a:stretch>
+            <a:fillRect/>
+          </a:stretch>
+        </p:blipFill>
+        <p:spPr>
+          <a:xfrm>
+            <a:off x="0" y="0"/>
+            <a:ext cx="12192000" cy="6858000"/>
+          </a:xfrm>
+          <a:prstGeom prst="rect">
+            <a:avLst/>
+          </a:prstGeom>
+        </p:spPr>
+      </p:pic>
+    </p:spTree>
+  </p:cSld>
+  <p:clrMapOvr>
+    <a:masterClrMapping/>
+  </p:clrMapOvr>
+</p:sld>
+</file>
+
+<file path=ppt/slides/slide14.xml><?xml version="1.0" encoding="utf-8"?>
+<p:sld xmlns:p="http://schemas.openxmlformats.org/presentationml/2006/main" xmlns:a="http://schemas.openxmlformats.org/drawingml/2006/main" xmlns:r="http://schemas.openxmlformats.org/officeDocument/2006/relationships">
+  <p:cSld name="slide-14">
+    <p:spTree>
+      <p:nvGrpSpPr>
+        <p:cNvPr id="1" name=""/>
+        <p:cNvGrpSpPr/>
+        <p:nvPr/>
+      </p:nvGrpSpPr>
+      <p:grpSpPr>
+        <a:xfrm>
+          <a:off x="0" y="0"/>
+          <a:ext cx="0" cy="0"/>
+          <a:chOff x="0" y="0"/>
+          <a:chExt cx="0" cy="0"/>
+        </a:xfrm>
+      </p:grpSpPr>
+      <p:pic>
+        <p:nvPicPr>
+          <p:cNvPr id="2" name="slide-14"/>
+          <p:cNvPicPr>
+            <a:picLocks noChangeAspect="1"/>
+          </p:cNvPicPr>
+          <p:nvPr/>
+        </p:nvPicPr>
+        <p:blipFill>
+          <a:blip r:embed="image"/>
+          <a:stretch>
+            <a:fillRect/>
+          </a:stretch>
+        </p:blipFill>
+        <p:spPr>
+          <a:xfrm>
+            <a:off x="0" y="0"/>
+            <a:ext cx="12192000" cy="6858000"/>
+          </a:xfrm>
+          <a:prstGeom prst="rect">
+            <a:avLst/>
+          </a:prstGeom>
+        </p:spPr>
+      </p:pic>
+    </p:spTree>
+  </p:cSld>
+  <p:clrMapOvr>
+    <a:masterClrMapping/>
+  </p:clrMapOvr>
+</p:sld>
+</file>
+
+<file path=ppt/slides/slide15.xml><?xml version="1.0" encoding="utf-8"?>
+<p:sld xmlns:p="http://schemas.openxmlformats.org/presentationml/2006/main" xmlns:a="http://schemas.openxmlformats.org/drawingml/2006/main" xmlns:r="http://schemas.openxmlformats.org/officeDocument/2006/relationships">
+  <p:cSld name="slide-15">
+    <p:spTree>
+      <p:nvGrpSpPr>
+        <p:cNvPr id="1" name=""/>
+        <p:cNvGrpSpPr/>
+        <p:nvPr/>
+      </p:nvGrpSpPr>
+      <p:grpSpPr>
+        <a:xfrm>
+          <a:off x="0" y="0"/>
+          <a:ext cx="0" cy="0"/>
+          <a:chOff x="0" y="0"/>
+          <a:chExt cx="0" cy="0"/>
+        </a:xfrm>
+      </p:grpSpPr>
+      <p:pic>
+        <p:nvPicPr>
+          <p:cNvPr id="2" name="slide-15"/>
+          <p:cNvPicPr>
+            <a:picLocks noChangeAspect="1"/>
+          </p:cNvPicPr>
+          <p:nvPr/>
+        </p:nvPicPr>
+        <p:blipFill>
+          <a:blip r:embed="image"/>
+          <a:stretch>
+            <a:fillRect/>
+          </a:stretch>
+        </p:blipFill>
+        <p:spPr>
+          <a:xfrm>
+            <a:off x="0" y="0"/>
+            <a:ext cx="12192000" cy="6858000"/>
+          </a:xfrm>
+          <a:prstGeom prst="rect">
+            <a:avLst/>
+          </a:prstGeom>
+        </p:spPr>
+      </p:pic>
+    </p:spTree>
+  </p:cSld>
+  <p:clrMapOvr>
+    <a:masterClrMapping/>
+  </p:clrMapOvr>
+</p:sld>
+</file>
+
+<file path=ppt/slides/slide16.xml><?xml version="1.0" encoding="utf-8"?>
+<p:sld xmlns:p="http://schemas.openxmlformats.org/presentationml/2006/main" xmlns:a="http://schemas.openxmlformats.org/drawingml/2006/main" xmlns:r="http://schemas.openxmlformats.org/officeDocument/2006/relationships">
+  <p:cSld name="slide-16">
+    <p:spTree>
+      <p:nvGrpSpPr>
+        <p:cNvPr id="1" name=""/>
+        <p:cNvGrpSpPr/>
+        <p:nvPr/>
+      </p:nvGrpSpPr>
+      <p:grpSpPr>
+        <a:xfrm>
+          <a:off x="0" y="0"/>
+          <a:ext cx="0" cy="0"/>
+          <a:chOff x="0" y="0"/>
+          <a:chExt cx="0" cy="0"/>
+        </a:xfrm>
+      </p:grpSpPr>
+      <p:pic>
+        <p:nvPicPr>
+          <p:cNvPr id="2" name="slide-16"/>
+          <p:cNvPicPr>
+            <a:picLocks noChangeAspect="1"/>
+          </p:cNvPicPr>
+          <p:nvPr/>
+        </p:nvPicPr>
+        <p:blipFill>
+          <a:blip r:embed="image"/>
+          <a:stretch>
+            <a:fillRect/>
+          </a:stretch>
+        </p:blipFill>
+        <p:spPr>
+          <a:xfrm>
+            <a:off x="0" y="0"/>
+            <a:ext cx="12192000" cy="6858000"/>
+          </a:xfrm>
+          <a:prstGeom prst="rect">
+            <a:avLst/>
+          </a:prstGeom>
+        </p:spPr>
+      </p:pic>
+    </p:spTree>
+  </p:cSld>
+  <p:clrMapOvr>
+    <a:masterClrMapping/>
+  </p:clrMapOvr>
+</p:sld>
+</file>
+
+<file path=ppt/slides/slide17.xml><?xml version="1.0" encoding="utf-8"?>
+<p:sld xmlns:p="http://schemas.openxmlformats.org/presentationml/2006/main" xmlns:a="http://schemas.openxmlformats.org/drawingml/2006/main" xmlns:r="http://schemas.openxmlformats.org/officeDocument/2006/relationships">
+  <p:cSld name="slide-17">
+    <p:spTree>
+      <p:nvGrpSpPr>
+        <p:cNvPr id="1" name=""/>
+        <p:cNvGrpSpPr/>
+        <p:nvPr/>
+      </p:nvGrpSpPr>
+      <p:grpSpPr>
+        <a:xfrm>
+          <a:off x="0" y="0"/>
+          <a:ext cx="0" cy="0"/>
+          <a:chOff x="0" y="0"/>
+          <a:chExt cx="0" cy="0"/>
+        </a:xfrm>
+      </p:grpSpPr>
+      <p:pic>
+        <p:nvPicPr>
+          <p:cNvPr id="2" name="slide-17"/>
+          <p:cNvPicPr>
+            <a:picLocks noChangeAspect="1"/>
+          </p:cNvPicPr>
+          <p:nvPr/>
+        </p:nvPicPr>
+        <p:blipFill>
+          <a:blip r:embed="image"/>
+          <a:stretch>
+            <a:fillRect/>
+          </a:stretch>
+        </p:blipFill>
+        <p:spPr>
+          <a:xfrm>
+            <a:off x="0" y="0"/>
+            <a:ext cx="12192000" cy="6858000"/>
+          </a:xfrm>
+          <a:prstGeom prst="rect">
+            <a:avLst/>
+          </a:prstGeom>
+        </p:spPr>
+      </p:pic>
+    </p:spTree>
+  </p:cSld>
+  <p:clrMapOvr>
+    <a:masterClrMapping/>
+  </p:clrMapOvr>
+</p:sld>
+</file>
+
+<file path=ppt/slides/slide18.xml><?xml version="1.0" encoding="utf-8"?>
+<p:sld xmlns:p="http://schemas.openxmlformats.org/presentationml/2006/main" xmlns:a="http://schemas.openxmlformats.org/drawingml/2006/main" xmlns:r="http://schemas.openxmlformats.org/officeDocument/2006/relationships">
+  <p:cSld name="slide-18">
+    <p:spTree>
+      <p:nvGrpSpPr>
+        <p:cNvPr id="1" name=""/>
+        <p:cNvGrpSpPr/>
+        <p:nvPr/>
+      </p:nvGrpSpPr>
+      <p:grpSpPr>
+        <a:xfrm>
+          <a:off x="0" y="0"/>
+          <a:ext cx="0" cy="0"/>
+          <a:chOff x="0" y="0"/>
+          <a:chExt cx="0" cy="0"/>
+        </a:xfrm>
+      </p:grpSpPr>
+      <p:pic>
+        <p:nvPicPr>
+          <p:cNvPr id="2" name="slide-18"/>
+          <p:cNvPicPr>
+            <a:picLocks noChangeAspect="1"/>
+          </p:cNvPicPr>
+          <p:nvPr/>
+        </p:nvPicPr>
+        <p:blipFill>
+          <a:blip r:embed="image"/>
+          <a:stretch>
+            <a:fillRect/>
+          </a:stretch>
+        </p:blipFill>
+        <p:spPr>
+          <a:xfrm>
+            <a:off x="0" y="0"/>
+            <a:ext cx="12192000" cy="6858000"/>
+          </a:xfrm>
+          <a:prstGeom prst="rect">
+            <a:avLst/>
+          </a:prstGeom>
+        </p:spPr>
+      </p:pic>
+    </p:spTree>
+  </p:cSld>
+  <p:clrMapOvr>
+    <a:masterClrMapping/>
+  </p:clrMapOvr>
+</p:sld>
+</file>
+
+<file path=ppt/slides/slide19.xml><?xml version="1.0" encoding="utf-8"?>
+<p:sld xmlns:p="http://schemas.openxmlformats.org/presentationml/2006/main" xmlns:a="http://schemas.openxmlformats.org/drawingml/2006/main" xmlns:r="http://schemas.openxmlformats.org/officeDocument/2006/relationships">
+  <p:cSld name="slide-19">
+    <p:spTree>
+      <p:nvGrpSpPr>
+        <p:cNvPr id="1" name=""/>
+        <p:cNvGrpSpPr/>
+        <p:nvPr/>
+      </p:nvGrpSpPr>
+      <p:grpSpPr>
+        <a:xfrm>
+          <a:off x="0" y="0"/>
+          <a:ext cx="0" cy="0"/>
+          <a:chOff x="0" y="0"/>
+          <a:chExt cx="0" cy="0"/>
+        </a:xfrm>
+      </p:grpSpPr>
+      <p:pic>
+        <p:nvPicPr>
+          <p:cNvPr id="2" name="slide-19"/>
+          <p:cNvPicPr>
+            <a:picLocks noChangeAspect="1"/>
+          </p:cNvPicPr>
+          <p:nvPr/>
+        </p:nvPicPr>
+        <p:blipFill>
+          <a:blip r:embed="image"/>
+          <a:stretch>
+            <a:fillRect/>
+          </a:stretch>
+        </p:blipFill>
+        <p:spPr>
+          <a:xfrm>
+            <a:off x="0" y="0"/>
+            <a:ext cx="12192000" cy="6858000"/>
+          </a:xfrm>
+          <a:prstGeom prst="rect">
+            <a:avLst/>
+          </a:prstGeom>
+        </p:spPr>
+      </p:pic>
+    </p:spTree>
+  </p:cSld>
+  <p:clrMapOvr>
+    <a:masterClrMapping/>
+  </p:clrMapOvr>
+</p:sld>
+</file>
+
 <file path=ppt/slides/slide2.xml><?xml version="1.0" encoding="utf-8"?>
 <p:sld xmlns:p="http://schemas.openxmlformats.org/presentationml/2006/main" xmlns:a="http://schemas.openxmlformats.org/drawingml/2006/main" xmlns:r="http://schemas.openxmlformats.org/officeDocument/2006/relationships">
   <p:cSld name="slide-02">
@@ -190,6 +642,104 @@
       <p:pic>
         <p:nvPicPr>
           <p:cNvPr id="2" name="slide-02"/>
+          <p:cNvPicPr>
+            <a:picLocks noChangeAspect="1"/>
+          </p:cNvPicPr>
+          <p:nvPr/>
+        </p:nvPicPr>
+        <p:blipFill>
+          <a:blip r:embed="image"/>
+          <a:stretch>
+            <a:fillRect/>
+          </a:stretch>
+        </p:blipFill>
+        <p:spPr>
+          <a:xfrm>
+            <a:off x="0" y="0"/>
+            <a:ext cx="12192000" cy="6858000"/>
+          </a:xfrm>
+          <a:prstGeom prst="rect">
+            <a:avLst/>
+          </a:prstGeom>
+        </p:spPr>
+      </p:pic>
+    </p:spTree>
+  </p:cSld>
+  <p:clrMapOvr>
+    <a:masterClrMapping/>
+  </p:clrMapOvr>
+</p:sld>
+</file>
+
+<file path=ppt/slides/slide20.xml><?xml version="1.0" encoding="utf-8"?>
+<p:sld xmlns:p="http://schemas.openxmlformats.org/presentationml/2006/main" xmlns:a="http://schemas.openxmlformats.org/drawingml/2006/main" xmlns:r="http://schemas.openxmlformats.org/officeDocument/2006/relationships">
+  <p:cSld name="slide-20">
+    <p:spTree>
+      <p:nvGrpSpPr>
+        <p:cNvPr id="1" name=""/>
+        <p:cNvGrpSpPr/>
+        <p:nvPr/>
+      </p:nvGrpSpPr>
+      <p:grpSpPr>
+        <a:xfrm>
+          <a:off x="0" y="0"/>
+          <a:ext cx="0" cy="0"/>
+          <a:chOff x="0" y="0"/>
+          <a:chExt cx="0" cy="0"/>
+        </a:xfrm>
+      </p:grpSpPr>
+      <p:pic>
+        <p:nvPicPr>
+          <p:cNvPr id="2" name="slide-20"/>
+          <p:cNvPicPr>
+            <a:picLocks noChangeAspect="1"/>
+          </p:cNvPicPr>
+          <p:nvPr/>
+        </p:nvPicPr>
+        <p:blipFill>
+          <a:blip r:embed="image"/>
+          <a:stretch>
+            <a:fillRect/>
+          </a:stretch>
+        </p:blipFill>
+        <p:spPr>
+          <a:xfrm>
+            <a:off x="0" y="0"/>
+            <a:ext cx="12192000" cy="6858000"/>
+          </a:xfrm>
+          <a:prstGeom prst="rect">
+            <a:avLst/>
+          </a:prstGeom>
+        </p:spPr>
+      </p:pic>
+    </p:spTree>
+  </p:cSld>
+  <p:clrMapOvr>
+    <a:masterClrMapping/>
+  </p:clrMapOvr>
+</p:sld>
+</file>
+
+<file path=ppt/slides/slide21.xml><?xml version="1.0" encoding="utf-8"?>
+<p:sld xmlns:p="http://schemas.openxmlformats.org/presentationml/2006/main" xmlns:a="http://schemas.openxmlformats.org/drawingml/2006/main" xmlns:r="http://schemas.openxmlformats.org/officeDocument/2006/relationships">
+  <p:cSld name="slide-21">
+    <p:spTree>
+      <p:nvGrpSpPr>
+        <p:cNvPr id="1" name=""/>
+        <p:cNvGrpSpPr/>
+        <p:nvPr/>
+      </p:nvGrpSpPr>
+      <p:grpSpPr>
+        <a:xfrm>
+          <a:off x="0" y="0"/>
+          <a:ext cx="0" cy="0"/>
+          <a:chOff x="0" y="0"/>
+          <a:chExt cx="0" cy="0"/>
+        </a:xfrm>
+      </p:grpSpPr>
+      <p:pic>
+        <p:nvPicPr>
+          <p:cNvPr id="2" name="slide-21"/>
           <p:cNvPicPr>
             <a:picLocks noChangeAspect="1"/>
           </p:cNvPicPr>

</xml_diff>